<commit_message>
velky update nahrani skillu a dokumentace
</commit_message>
<xml_diff>
--- a/skills/xlab-pptx-template/assets/XLAB_PPT_ALL.pptx
+++ b/skills/xlab-pptx-template/assets/XLAB_PPT_ALL.pptx
@@ -113,14 +113,6 @@
 </p:presentation>
 </file>
 
-<file path=ppt/revisionInfo.xml><?xml version="1.0" encoding="utf-8"?>
-<p1510:revInfo xmlns:a="http://schemas.openxmlformats.org/drawingml/2006/main" xmlns:r="http://schemas.openxmlformats.org/officeDocument/2006/relationships" xmlns:p1510="http://schemas.microsoft.com/office/powerpoint/2015/10/main">
-  <p1510:revLst>
-    <p1510:client id="{CD8369C7-344B-084C-A5DB-8B627E5C9747}" v="282" dt="2026-02-16T00:55:43.710"/>
-  </p1510:revLst>
-</p1510:revInfo>
-</file>
-
 <file path=ppt/notesMasters/notesMaster1.xml><?xml version="1.0" encoding="utf-8"?>
 <p:notesMaster xmlns:a="http://schemas.openxmlformats.org/drawingml/2006/main" xmlns:r="http://schemas.openxmlformats.org/officeDocument/2006/relationships" xmlns:p="http://schemas.openxmlformats.org/presentationml/2006/main">
   <p:cSld>
@@ -203,7 +195,7 @@
           <a:p>
             <a:fld id="{E0B74DDB-D089-8942-8189-37AE4FB88DFE}" type="datetimeFigureOut">
               <a:rPr lang="en-US" smtClean="0"/>
-              <a:t>2/16/26</a:t>
+              <a:t>2/18/26</a:t>
             </a:fld>
             <a:endParaRPr lang="en-US"/>
           </a:p>
@@ -1860,7 +1852,7 @@
           </a:ln>
           <a:extLst>
             <a:ext uri="{C572A759-6A51-4108-AA02-DFA0A04FC94B}">
-              <ma14:wrappingTextBoxFlag xmlns="" xmlns:m="http://schemas.openxmlformats.org/officeDocument/2006/math" xmlns:a14="http://schemas.microsoft.com/office/drawing/2010/main" xmlns:ma14="http://schemas.microsoft.com/office/mac/drawingml/2011/main" val="1"/>
+              <ma14:wrappingTextBoxFlag xmlns:ma14="http://schemas.microsoft.com/office/mac/drawingml/2011/main" xmlns:a14="http://schemas.microsoft.com/office/drawing/2010/main" xmlns:m="http://schemas.openxmlformats.org/officeDocument/2006/math" xmlns="" val="1"/>
             </a:ext>
           </a:extLst>
         </p:spPr>
@@ -1917,7 +1909,7 @@
           </a:ln>
           <a:extLst>
             <a:ext uri="{C572A759-6A51-4108-AA02-DFA0A04FC94B}">
-              <ma14:wrappingTextBoxFlag xmlns="" xmlns:m="http://schemas.openxmlformats.org/officeDocument/2006/math" xmlns:a14="http://schemas.microsoft.com/office/drawing/2010/main" xmlns:ma14="http://schemas.microsoft.com/office/mac/drawingml/2011/main" val="1"/>
+              <ma14:wrappingTextBoxFlag xmlns:ma14="http://schemas.microsoft.com/office/mac/drawingml/2011/main" xmlns:a14="http://schemas.microsoft.com/office/drawing/2010/main" xmlns:m="http://schemas.openxmlformats.org/officeDocument/2006/math" xmlns="" val="1"/>
             </a:ext>
           </a:extLst>
         </p:spPr>
@@ -2116,7 +2108,7 @@
               </a:ln>
               <a:extLst>
                 <a:ext uri="{C572A759-6A51-4108-AA02-DFA0A04FC94B}">
-                  <ma14:wrappingTextBoxFlag xmlns="" xmlns:m="http://schemas.openxmlformats.org/officeDocument/2006/math" xmlns:a14="http://schemas.microsoft.com/office/drawing/2010/main" xmlns:ma14="http://schemas.microsoft.com/office/mac/drawingml/2011/main" val="1"/>
+                  <ma14:wrappingTextBoxFlag xmlns:ma14="http://schemas.microsoft.com/office/mac/drawingml/2011/main" xmlns:a14="http://schemas.microsoft.com/office/drawing/2010/main" xmlns:m="http://schemas.openxmlformats.org/officeDocument/2006/math" xmlns="" val="1"/>
                 </a:ext>
               </a:extLst>
             </p:spPr>
@@ -2173,7 +2165,7 @@
               </a:ln>
               <a:extLst>
                 <a:ext uri="{C572A759-6A51-4108-AA02-DFA0A04FC94B}">
-                  <ma14:wrappingTextBoxFlag xmlns="" xmlns:m="http://schemas.openxmlformats.org/officeDocument/2006/math" xmlns:a14="http://schemas.microsoft.com/office/drawing/2010/main" xmlns:ma14="http://schemas.microsoft.com/office/mac/drawingml/2011/main" val="1"/>
+                  <ma14:wrappingTextBoxFlag xmlns:ma14="http://schemas.microsoft.com/office/mac/drawingml/2011/main" xmlns:a14="http://schemas.microsoft.com/office/drawing/2010/main" xmlns:m="http://schemas.openxmlformats.org/officeDocument/2006/math" xmlns="" val="1"/>
                 </a:ext>
               </a:extLst>
             </p:spPr>
@@ -2250,7 +2242,7 @@
             </a:ln>
             <a:extLst>
               <a:ext uri="{C572A759-6A51-4108-AA02-DFA0A04FC94B}">
-                <ma14:wrappingTextBoxFlag xmlns="" xmlns:m="http://schemas.openxmlformats.org/officeDocument/2006/math" xmlns:a14="http://schemas.microsoft.com/office/drawing/2010/main" xmlns:ma14="http://schemas.microsoft.com/office/mac/drawingml/2011/main" val="1"/>
+                <ma14:wrappingTextBoxFlag xmlns:ma14="http://schemas.microsoft.com/office/mac/drawingml/2011/main" xmlns:a14="http://schemas.microsoft.com/office/drawing/2010/main" xmlns:m="http://schemas.openxmlformats.org/officeDocument/2006/math" xmlns="" val="1"/>
               </a:ext>
             </a:extLst>
           </p:spPr>
@@ -2329,7 +2321,7 @@
             </a:ln>
             <a:extLst>
               <a:ext uri="{C572A759-6A51-4108-AA02-DFA0A04FC94B}">
-                <ma14:wrappingTextBoxFlag xmlns="" xmlns:m="http://schemas.openxmlformats.org/officeDocument/2006/math" xmlns:a14="http://schemas.microsoft.com/office/drawing/2010/main" xmlns:ma14="http://schemas.microsoft.com/office/mac/drawingml/2011/main" val="1"/>
+                <ma14:wrappingTextBoxFlag xmlns:ma14="http://schemas.microsoft.com/office/mac/drawingml/2011/main" xmlns:a14="http://schemas.microsoft.com/office/drawing/2010/main" xmlns:m="http://schemas.openxmlformats.org/officeDocument/2006/math" xmlns="" val="1"/>
               </a:ext>
             </a:extLst>
           </p:spPr>
@@ -2465,7 +2457,7 @@
             </a:ln>
             <a:extLst>
               <a:ext uri="{C572A759-6A51-4108-AA02-DFA0A04FC94B}">
-                <ma14:wrappingTextBoxFlag xmlns="" xmlns:m="http://schemas.openxmlformats.org/officeDocument/2006/math" xmlns:a14="http://schemas.microsoft.com/office/drawing/2010/main" xmlns:ma14="http://schemas.microsoft.com/office/mac/drawingml/2011/main" val="1"/>
+                <ma14:wrappingTextBoxFlag xmlns:ma14="http://schemas.microsoft.com/office/mac/drawingml/2011/main" xmlns:a14="http://schemas.microsoft.com/office/drawing/2010/main" xmlns:m="http://schemas.openxmlformats.org/officeDocument/2006/math" xmlns="" val="1"/>
               </a:ext>
             </a:extLst>
           </p:spPr>
@@ -2563,7 +2555,7 @@
           </a:ln>
           <a:extLst>
             <a:ext uri="{C572A759-6A51-4108-AA02-DFA0A04FC94B}">
-              <ma14:wrappingTextBoxFlag xmlns="" xmlns:m="http://schemas.openxmlformats.org/officeDocument/2006/math" xmlns:a14="http://schemas.microsoft.com/office/drawing/2010/main" xmlns:ma14="http://schemas.microsoft.com/office/mac/drawingml/2011/main" val="1"/>
+              <ma14:wrappingTextBoxFlag xmlns:ma14="http://schemas.microsoft.com/office/mac/drawingml/2011/main" xmlns:a14="http://schemas.microsoft.com/office/drawing/2010/main" xmlns:m="http://schemas.openxmlformats.org/officeDocument/2006/math" xmlns="" val="1"/>
             </a:ext>
           </a:extLst>
         </p:spPr>
@@ -2655,7 +2647,7 @@
           </a:ln>
           <a:extLst>
             <a:ext uri="{C572A759-6A51-4108-AA02-DFA0A04FC94B}">
-              <ma14:wrappingTextBoxFlag xmlns="" xmlns:m="http://schemas.openxmlformats.org/officeDocument/2006/math" xmlns:a14="http://schemas.microsoft.com/office/drawing/2010/main" xmlns:ma14="http://schemas.microsoft.com/office/mac/drawingml/2011/main" val="1"/>
+              <ma14:wrappingTextBoxFlag xmlns:ma14="http://schemas.microsoft.com/office/mac/drawingml/2011/main" xmlns:a14="http://schemas.microsoft.com/office/drawing/2010/main" xmlns:m="http://schemas.openxmlformats.org/officeDocument/2006/math" xmlns="" val="1"/>
             </a:ext>
           </a:extLst>
         </p:spPr>
@@ -2740,7 +2732,7 @@
           </a:ln>
           <a:extLst>
             <a:ext uri="{C572A759-6A51-4108-AA02-DFA0A04FC94B}">
-              <ma14:wrappingTextBoxFlag xmlns="" xmlns:m="http://schemas.openxmlformats.org/officeDocument/2006/math" xmlns:a14="http://schemas.microsoft.com/office/drawing/2010/main" xmlns:ma14="http://schemas.microsoft.com/office/mac/drawingml/2011/main" val="1"/>
+              <ma14:wrappingTextBoxFlag xmlns:ma14="http://schemas.microsoft.com/office/mac/drawingml/2011/main" xmlns:a14="http://schemas.microsoft.com/office/drawing/2010/main" xmlns:m="http://schemas.openxmlformats.org/officeDocument/2006/math" xmlns="" val="1"/>
             </a:ext>
           </a:extLst>
         </p:spPr>
@@ -2825,7 +2817,7 @@
           </a:ln>
           <a:extLst>
             <a:ext uri="{C572A759-6A51-4108-AA02-DFA0A04FC94B}">
-              <ma14:wrappingTextBoxFlag xmlns="" xmlns:m="http://schemas.openxmlformats.org/officeDocument/2006/math" xmlns:a14="http://schemas.microsoft.com/office/drawing/2010/main" xmlns:ma14="http://schemas.microsoft.com/office/mac/drawingml/2011/main" val="1"/>
+              <ma14:wrappingTextBoxFlag xmlns:ma14="http://schemas.microsoft.com/office/mac/drawingml/2011/main" xmlns:a14="http://schemas.microsoft.com/office/drawing/2010/main" xmlns:m="http://schemas.openxmlformats.org/officeDocument/2006/math" xmlns="" val="1"/>
             </a:ext>
           </a:extLst>
         </p:spPr>
@@ -3008,6 +3000,36 @@
           <a:chExt cx="0" cy="0"/>
         </a:xfrm>
       </p:grpSpPr>
+      <p:pic>
+        <p:nvPicPr>
+          <p:cNvPr id="5" name="Picture 4" descr="A black and grey background&#10;&#10;AI-generated content may be incorrect.">
+            <a:extLst>
+              <a:ext uri="{FF2B5EF4-FFF2-40B4-BE49-F238E27FC236}">
+                <a16:creationId xmlns:a16="http://schemas.microsoft.com/office/drawing/2014/main" id="{87DCA494-36E7-3EA2-AFA4-A98D9176D472}"/>
+              </a:ext>
+            </a:extLst>
+          </p:cNvPr>
+          <p:cNvPicPr>
+            <a:picLocks noChangeAspect="1"/>
+          </p:cNvPicPr>
+          <p:nvPr userDrawn="1"/>
+        </p:nvPicPr>
+        <p:blipFill>
+          <a:blip r:embed="rId2"/>
+          <a:stretch>
+            <a:fillRect/>
+          </a:stretch>
+        </p:blipFill>
+        <p:spPr>
+          <a:xfrm>
+            <a:off x="7632700" y="0"/>
+            <a:ext cx="4559300" cy="6858000"/>
+          </a:xfrm>
+          <a:prstGeom prst="rect">
+            <a:avLst/>
+          </a:prstGeom>
+        </p:spPr>
+      </p:pic>
       <p:sp>
         <p:nvSpPr>
           <p:cNvPr id="2" name="Title 1">
@@ -3181,38 +3203,6 @@
           </a:fontRef>
         </p:style>
       </p:cxnSp>
-      <p:pic>
-        <p:nvPicPr>
-          <p:cNvPr id="7" name="Picture 6" descr="A grey triangle shaped object&#10;&#10;Description automatically generated">
-            <a:extLst>
-              <a:ext uri="{FF2B5EF4-FFF2-40B4-BE49-F238E27FC236}">
-                <a16:creationId xmlns:a16="http://schemas.microsoft.com/office/drawing/2014/main" id="{57727967-3FC2-0DF1-03F3-3F4BD7AF7B9B}"/>
-              </a:ext>
-            </a:extLst>
-          </p:cNvPr>
-          <p:cNvPicPr>
-            <a:picLocks noChangeAspect="1"/>
-          </p:cNvPicPr>
-          <p:nvPr userDrawn="1"/>
-        </p:nvPicPr>
-        <p:blipFill>
-          <a:blip r:embed="rId2">
-            <a:alphaModFix amt="32000"/>
-          </a:blip>
-          <a:stretch>
-            <a:fillRect/>
-          </a:stretch>
-        </p:blipFill>
-        <p:spPr>
-          <a:xfrm>
-            <a:off x="7622925" y="0"/>
-            <a:ext cx="4560780" cy="6858000"/>
-          </a:xfrm>
-          <a:prstGeom prst="rect">
-            <a:avLst/>
-          </a:prstGeom>
-        </p:spPr>
-      </p:pic>
     </p:spTree>
     <p:extLst>
       <p:ext uri="{BB962C8B-B14F-4D97-AF65-F5344CB8AC3E}">
@@ -7389,7 +7379,7 @@
           </a:ln>
           <a:extLst>
             <a:ext uri="{C572A759-6A51-4108-AA02-DFA0A04FC94B}">
-              <ma14:wrappingTextBoxFlag xmlns="" xmlns:m="http://schemas.openxmlformats.org/officeDocument/2006/math" xmlns:a14="http://schemas.microsoft.com/office/drawing/2010/main" xmlns:ma14="http://schemas.microsoft.com/office/mac/drawingml/2011/main" val="1"/>
+              <ma14:wrappingTextBoxFlag xmlns:ma14="http://schemas.microsoft.com/office/mac/drawingml/2011/main" xmlns:a14="http://schemas.microsoft.com/office/drawing/2010/main" xmlns:m="http://schemas.openxmlformats.org/officeDocument/2006/math" xmlns="" val="1"/>
             </a:ext>
           </a:extLst>
         </p:spPr>
@@ -7446,7 +7436,7 @@
           </a:ln>
           <a:extLst>
             <a:ext uri="{C572A759-6A51-4108-AA02-DFA0A04FC94B}">
-              <ma14:wrappingTextBoxFlag xmlns="" xmlns:m="http://schemas.openxmlformats.org/officeDocument/2006/math" xmlns:a14="http://schemas.microsoft.com/office/drawing/2010/main" xmlns:ma14="http://schemas.microsoft.com/office/mac/drawingml/2011/main" val="1"/>
+              <ma14:wrappingTextBoxFlag xmlns:ma14="http://schemas.microsoft.com/office/mac/drawingml/2011/main" xmlns:a14="http://schemas.microsoft.com/office/drawing/2010/main" xmlns:m="http://schemas.openxmlformats.org/officeDocument/2006/math" xmlns="" val="1"/>
             </a:ext>
           </a:extLst>
         </p:spPr>
@@ -7663,7 +7653,7 @@
               </a:ln>
               <a:extLst>
                 <a:ext uri="{C572A759-6A51-4108-AA02-DFA0A04FC94B}">
-                  <ma14:wrappingTextBoxFlag xmlns="" xmlns:m="http://schemas.openxmlformats.org/officeDocument/2006/math" xmlns:a14="http://schemas.microsoft.com/office/drawing/2010/main" xmlns:ma14="http://schemas.microsoft.com/office/mac/drawingml/2011/main" val="1"/>
+                  <ma14:wrappingTextBoxFlag xmlns:ma14="http://schemas.microsoft.com/office/mac/drawingml/2011/main" xmlns:a14="http://schemas.microsoft.com/office/drawing/2010/main" xmlns:m="http://schemas.openxmlformats.org/officeDocument/2006/math" xmlns="" val="1"/>
                 </a:ext>
               </a:extLst>
             </p:spPr>
@@ -7724,7 +7714,7 @@
               </a:ln>
               <a:extLst>
                 <a:ext uri="{C572A759-6A51-4108-AA02-DFA0A04FC94B}">
-                  <ma14:wrappingTextBoxFlag xmlns="" xmlns:m="http://schemas.openxmlformats.org/officeDocument/2006/math" xmlns:a14="http://schemas.microsoft.com/office/drawing/2010/main" xmlns:ma14="http://schemas.microsoft.com/office/mac/drawingml/2011/main" val="1"/>
+                  <ma14:wrappingTextBoxFlag xmlns:ma14="http://schemas.microsoft.com/office/mac/drawingml/2011/main" xmlns:a14="http://schemas.microsoft.com/office/drawing/2010/main" xmlns:m="http://schemas.openxmlformats.org/officeDocument/2006/math" xmlns="" val="1"/>
                 </a:ext>
               </a:extLst>
             </p:spPr>
@@ -7801,7 +7791,7 @@
             </a:ln>
             <a:extLst>
               <a:ext uri="{C572A759-6A51-4108-AA02-DFA0A04FC94B}">
-                <ma14:wrappingTextBoxFlag xmlns="" xmlns:m="http://schemas.openxmlformats.org/officeDocument/2006/math" xmlns:a14="http://schemas.microsoft.com/office/drawing/2010/main" xmlns:ma14="http://schemas.microsoft.com/office/mac/drawingml/2011/main" val="1"/>
+                <ma14:wrappingTextBoxFlag xmlns:ma14="http://schemas.microsoft.com/office/mac/drawingml/2011/main" xmlns:a14="http://schemas.microsoft.com/office/drawing/2010/main" xmlns:m="http://schemas.openxmlformats.org/officeDocument/2006/math" xmlns="" val="1"/>
               </a:ext>
             </a:extLst>
           </p:spPr>
@@ -7880,7 +7870,7 @@
             </a:ln>
             <a:extLst>
               <a:ext uri="{C572A759-6A51-4108-AA02-DFA0A04FC94B}">
-                <ma14:wrappingTextBoxFlag xmlns="" xmlns:m="http://schemas.openxmlformats.org/officeDocument/2006/math" xmlns:a14="http://schemas.microsoft.com/office/drawing/2010/main" xmlns:ma14="http://schemas.microsoft.com/office/mac/drawingml/2011/main" val="1"/>
+                <ma14:wrappingTextBoxFlag xmlns:ma14="http://schemas.microsoft.com/office/mac/drawingml/2011/main" xmlns:a14="http://schemas.microsoft.com/office/drawing/2010/main" xmlns:m="http://schemas.openxmlformats.org/officeDocument/2006/math" xmlns="" val="1"/>
               </a:ext>
             </a:extLst>
           </p:spPr>
@@ -8025,7 +8015,7 @@
             </a:ln>
             <a:extLst>
               <a:ext uri="{C572A759-6A51-4108-AA02-DFA0A04FC94B}">
-                <ma14:wrappingTextBoxFlag xmlns="" xmlns:m="http://schemas.openxmlformats.org/officeDocument/2006/math" xmlns:a14="http://schemas.microsoft.com/office/drawing/2010/main" xmlns:ma14="http://schemas.microsoft.com/office/mac/drawingml/2011/main" val="1"/>
+                <ma14:wrappingTextBoxFlag xmlns:ma14="http://schemas.microsoft.com/office/mac/drawingml/2011/main" xmlns:a14="http://schemas.microsoft.com/office/drawing/2010/main" xmlns:m="http://schemas.openxmlformats.org/officeDocument/2006/math" xmlns="" val="1"/>
               </a:ext>
             </a:extLst>
           </p:spPr>
@@ -8132,7 +8122,7 @@
           </a:ln>
           <a:extLst>
             <a:ext uri="{C572A759-6A51-4108-AA02-DFA0A04FC94B}">
-              <ma14:wrappingTextBoxFlag xmlns="" xmlns:m="http://schemas.openxmlformats.org/officeDocument/2006/math" xmlns:a14="http://schemas.microsoft.com/office/drawing/2010/main" xmlns:ma14="http://schemas.microsoft.com/office/mac/drawingml/2011/main" val="1"/>
+              <ma14:wrappingTextBoxFlag xmlns:ma14="http://schemas.microsoft.com/office/mac/drawingml/2011/main" xmlns:a14="http://schemas.microsoft.com/office/drawing/2010/main" xmlns:m="http://schemas.openxmlformats.org/officeDocument/2006/math" xmlns="" val="1"/>
             </a:ext>
           </a:extLst>
         </p:spPr>
@@ -8236,7 +8226,7 @@
           </a:ln>
           <a:extLst>
             <a:ext uri="{C572A759-6A51-4108-AA02-DFA0A04FC94B}">
-              <ma14:wrappingTextBoxFlag xmlns="" xmlns:m="http://schemas.openxmlformats.org/officeDocument/2006/math" xmlns:a14="http://schemas.microsoft.com/office/drawing/2010/main" xmlns:ma14="http://schemas.microsoft.com/office/mac/drawingml/2011/main" val="1"/>
+              <ma14:wrappingTextBoxFlag xmlns:ma14="http://schemas.microsoft.com/office/mac/drawingml/2011/main" xmlns:a14="http://schemas.microsoft.com/office/drawing/2010/main" xmlns:m="http://schemas.openxmlformats.org/officeDocument/2006/math" xmlns="" val="1"/>
             </a:ext>
           </a:extLst>
         </p:spPr>
@@ -8327,7 +8317,7 @@
           </a:ln>
           <a:extLst>
             <a:ext uri="{C572A759-6A51-4108-AA02-DFA0A04FC94B}">
-              <ma14:wrappingTextBoxFlag xmlns="" xmlns:m="http://schemas.openxmlformats.org/officeDocument/2006/math" xmlns:a14="http://schemas.microsoft.com/office/drawing/2010/main" xmlns:ma14="http://schemas.microsoft.com/office/mac/drawingml/2011/main" val="1"/>
+              <ma14:wrappingTextBoxFlag xmlns:ma14="http://schemas.microsoft.com/office/mac/drawingml/2011/main" xmlns:a14="http://schemas.microsoft.com/office/drawing/2010/main" xmlns:m="http://schemas.openxmlformats.org/officeDocument/2006/math" xmlns="" val="1"/>
             </a:ext>
           </a:extLst>
         </p:spPr>
@@ -8418,7 +8408,7 @@
           </a:ln>
           <a:extLst>
             <a:ext uri="{C572A759-6A51-4108-AA02-DFA0A04FC94B}">
-              <ma14:wrappingTextBoxFlag xmlns="" xmlns:m="http://schemas.openxmlformats.org/officeDocument/2006/math" xmlns:a14="http://schemas.microsoft.com/office/drawing/2010/main" xmlns:ma14="http://schemas.microsoft.com/office/mac/drawingml/2011/main" val="1"/>
+              <ma14:wrappingTextBoxFlag xmlns:ma14="http://schemas.microsoft.com/office/mac/drawingml/2011/main" xmlns:a14="http://schemas.microsoft.com/office/drawing/2010/main" xmlns:m="http://schemas.openxmlformats.org/officeDocument/2006/math" xmlns="" val="1"/>
             </a:ext>
           </a:extLst>
         </p:spPr>

</xml_diff>